<commit_message>
feat: Judge高度随blend缩放 + 新增Renda/Balloon/Roll资源及相关脚本
</commit_message>
<xml_diff>
--- a/ImitationTaikoUI.pptx
+++ b/ImitationTaikoUI.pptx
@@ -262,7 +262,7 @@
           <a:p>
             <a:fld id="{AF7C0022-D722-4CC5-A0B1-D94CF606F81D}" type="datetimeFigureOut">
               <a:rPr lang="zh-CN" altLang="en-US" smtClean="0"/>
-              <a:t>2026/6/13</a:t>
+              <a:t>2026/6/16</a:t>
             </a:fld>
             <a:endParaRPr lang="zh-CN" altLang="en-US"/>
           </a:p>
@@ -460,7 +460,7 @@
           <a:p>
             <a:fld id="{AF7C0022-D722-4CC5-A0B1-D94CF606F81D}" type="datetimeFigureOut">
               <a:rPr lang="zh-CN" altLang="en-US" smtClean="0"/>
-              <a:t>2026/6/13</a:t>
+              <a:t>2026/6/16</a:t>
             </a:fld>
             <a:endParaRPr lang="zh-CN" altLang="en-US"/>
           </a:p>
@@ -668,7 +668,7 @@
           <a:p>
             <a:fld id="{AF7C0022-D722-4CC5-A0B1-D94CF606F81D}" type="datetimeFigureOut">
               <a:rPr lang="zh-CN" altLang="en-US" smtClean="0"/>
-              <a:t>2026/6/13</a:t>
+              <a:t>2026/6/16</a:t>
             </a:fld>
             <a:endParaRPr lang="zh-CN" altLang="en-US"/>
           </a:p>
@@ -866,7 +866,7 @@
           <a:p>
             <a:fld id="{AF7C0022-D722-4CC5-A0B1-D94CF606F81D}" type="datetimeFigureOut">
               <a:rPr lang="zh-CN" altLang="en-US" smtClean="0"/>
-              <a:t>2026/6/13</a:t>
+              <a:t>2026/6/16</a:t>
             </a:fld>
             <a:endParaRPr lang="zh-CN" altLang="en-US"/>
           </a:p>
@@ -1141,7 +1141,7 @@
           <a:p>
             <a:fld id="{AF7C0022-D722-4CC5-A0B1-D94CF606F81D}" type="datetimeFigureOut">
               <a:rPr lang="zh-CN" altLang="en-US" smtClean="0"/>
-              <a:t>2026/6/13</a:t>
+              <a:t>2026/6/16</a:t>
             </a:fld>
             <a:endParaRPr lang="zh-CN" altLang="en-US"/>
           </a:p>
@@ -1406,7 +1406,7 @@
           <a:p>
             <a:fld id="{AF7C0022-D722-4CC5-A0B1-D94CF606F81D}" type="datetimeFigureOut">
               <a:rPr lang="zh-CN" altLang="en-US" smtClean="0"/>
-              <a:t>2026/6/13</a:t>
+              <a:t>2026/6/16</a:t>
             </a:fld>
             <a:endParaRPr lang="zh-CN" altLang="en-US"/>
           </a:p>
@@ -1818,7 +1818,7 @@
           <a:p>
             <a:fld id="{AF7C0022-D722-4CC5-A0B1-D94CF606F81D}" type="datetimeFigureOut">
               <a:rPr lang="zh-CN" altLang="en-US" smtClean="0"/>
-              <a:t>2026/6/13</a:t>
+              <a:t>2026/6/16</a:t>
             </a:fld>
             <a:endParaRPr lang="zh-CN" altLang="en-US"/>
           </a:p>
@@ -1959,7 +1959,7 @@
           <a:p>
             <a:fld id="{AF7C0022-D722-4CC5-A0B1-D94CF606F81D}" type="datetimeFigureOut">
               <a:rPr lang="zh-CN" altLang="en-US" smtClean="0"/>
-              <a:t>2026/6/13</a:t>
+              <a:t>2026/6/16</a:t>
             </a:fld>
             <a:endParaRPr lang="zh-CN" altLang="en-US"/>
           </a:p>
@@ -2072,7 +2072,7 @@
           <a:p>
             <a:fld id="{AF7C0022-D722-4CC5-A0B1-D94CF606F81D}" type="datetimeFigureOut">
               <a:rPr lang="zh-CN" altLang="en-US" smtClean="0"/>
-              <a:t>2026/6/13</a:t>
+              <a:t>2026/6/16</a:t>
             </a:fld>
             <a:endParaRPr lang="zh-CN" altLang="en-US"/>
           </a:p>
@@ -2383,7 +2383,7 @@
           <a:p>
             <a:fld id="{AF7C0022-D722-4CC5-A0B1-D94CF606F81D}" type="datetimeFigureOut">
               <a:rPr lang="zh-CN" altLang="en-US" smtClean="0"/>
-              <a:t>2026/6/13</a:t>
+              <a:t>2026/6/16</a:t>
             </a:fld>
             <a:endParaRPr lang="zh-CN" altLang="en-US"/>
           </a:p>
@@ -2671,7 +2671,7 @@
           <a:p>
             <a:fld id="{AF7C0022-D722-4CC5-A0B1-D94CF606F81D}" type="datetimeFigureOut">
               <a:rPr lang="zh-CN" altLang="en-US" smtClean="0"/>
-              <a:t>2026/6/13</a:t>
+              <a:t>2026/6/16</a:t>
             </a:fld>
             <a:endParaRPr lang="zh-CN" altLang="en-US"/>
           </a:p>
@@ -2912,7 +2912,7 @@
           <a:p>
             <a:fld id="{AF7C0022-D722-4CC5-A0B1-D94CF606F81D}" type="datetimeFigureOut">
               <a:rPr lang="zh-CN" altLang="en-US" smtClean="0"/>
-              <a:t>2026/6/13</a:t>
+              <a:t>2026/6/16</a:t>
             </a:fld>
             <a:endParaRPr lang="zh-CN" altLang="en-US"/>
           </a:p>
@@ -11292,6 +11292,183 @@
           </p:txBody>
         </p:sp>
       </p:grpSp>
+      <p:grpSp>
+        <p:nvGrpSpPr>
+          <p:cNvPr id="5" name="组合 4">
+            <a:extLst>
+              <a:ext uri="{FF2B5EF4-FFF2-40B4-BE49-F238E27FC236}">
+                <a16:creationId xmlns:a16="http://schemas.microsoft.com/office/drawing/2014/main" id="{5F88655F-72F8-E77D-D8FE-CBA44B24B739}"/>
+              </a:ext>
+            </a:extLst>
+          </p:cNvPr>
+          <p:cNvGrpSpPr/>
+          <p:nvPr/>
+        </p:nvGrpSpPr>
+        <p:grpSpPr>
+          <a:xfrm>
+            <a:off x="6320809" y="2444480"/>
+            <a:ext cx="720000" cy="720000"/>
+            <a:chOff x="1353600" y="1245600"/>
+            <a:chExt cx="720000" cy="720000"/>
+          </a:xfrm>
+        </p:grpSpPr>
+        <p:sp>
+          <p:nvSpPr>
+            <p:cNvPr id="6" name="椭圆 5">
+              <a:extLst>
+                <a:ext uri="{FF2B5EF4-FFF2-40B4-BE49-F238E27FC236}">
+                  <a16:creationId xmlns:a16="http://schemas.microsoft.com/office/drawing/2014/main" id="{EDD726FA-E49E-8288-CE8F-F4E0E0E50F00}"/>
+                </a:ext>
+              </a:extLst>
+            </p:cNvPr>
+            <p:cNvSpPr/>
+            <p:nvPr/>
+          </p:nvSpPr>
+          <p:spPr>
+            <a:xfrm>
+              <a:off x="1353600" y="1245600"/>
+              <a:ext cx="720000" cy="720000"/>
+            </a:xfrm>
+            <a:prstGeom prst="ellipse">
+              <a:avLst/>
+            </a:prstGeom>
+            <a:solidFill>
+              <a:srgbClr val="141311"/>
+            </a:solidFill>
+            <a:ln>
+              <a:noFill/>
+            </a:ln>
+          </p:spPr>
+          <p:style>
+            <a:lnRef idx="2">
+              <a:schemeClr val="accent1">
+                <a:shade val="15000"/>
+              </a:schemeClr>
+            </a:lnRef>
+            <a:fillRef idx="1">
+              <a:schemeClr val="accent1"/>
+            </a:fillRef>
+            <a:effectRef idx="0">
+              <a:schemeClr val="accent1"/>
+            </a:effectRef>
+            <a:fontRef idx="minor">
+              <a:schemeClr val="lt1"/>
+            </a:fontRef>
+          </p:style>
+          <p:txBody>
+            <a:bodyPr rtlCol="0" anchor="ctr"/>
+            <a:lstStyle/>
+            <a:p>
+              <a:pPr algn="ctr"/>
+              <a:endParaRPr lang="zh-CN" altLang="en-US"/>
+            </a:p>
+          </p:txBody>
+        </p:sp>
+        <p:sp>
+          <p:nvSpPr>
+            <p:cNvPr id="18" name="椭圆 17">
+              <a:extLst>
+                <a:ext uri="{FF2B5EF4-FFF2-40B4-BE49-F238E27FC236}">
+                  <a16:creationId xmlns:a16="http://schemas.microsoft.com/office/drawing/2014/main" id="{4183D905-9510-48C5-1105-73B49647941F}"/>
+                </a:ext>
+              </a:extLst>
+            </p:cNvPr>
+            <p:cNvSpPr/>
+            <p:nvPr/>
+          </p:nvSpPr>
+          <p:spPr>
+            <a:xfrm>
+              <a:off x="1389600" y="1281600"/>
+              <a:ext cx="648000" cy="648000"/>
+            </a:xfrm>
+            <a:prstGeom prst="ellipse">
+              <a:avLst/>
+            </a:prstGeom>
+            <a:solidFill>
+              <a:srgbClr val="F4EFDE"/>
+            </a:solidFill>
+            <a:ln>
+              <a:noFill/>
+            </a:ln>
+          </p:spPr>
+          <p:style>
+            <a:lnRef idx="2">
+              <a:schemeClr val="accent1">
+                <a:shade val="15000"/>
+              </a:schemeClr>
+            </a:lnRef>
+            <a:fillRef idx="1">
+              <a:schemeClr val="accent1"/>
+            </a:fillRef>
+            <a:effectRef idx="0">
+              <a:schemeClr val="accent1"/>
+            </a:effectRef>
+            <a:fontRef idx="minor">
+              <a:schemeClr val="lt1"/>
+            </a:fontRef>
+          </p:style>
+          <p:txBody>
+            <a:bodyPr rtlCol="0" anchor="ctr"/>
+            <a:lstStyle/>
+            <a:p>
+              <a:pPr algn="ctr"/>
+              <a:endParaRPr lang="zh-CN" altLang="en-US"/>
+            </a:p>
+          </p:txBody>
+        </p:sp>
+        <p:sp>
+          <p:nvSpPr>
+            <p:cNvPr id="23" name="椭圆 22">
+              <a:extLst>
+                <a:ext uri="{FF2B5EF4-FFF2-40B4-BE49-F238E27FC236}">
+                  <a16:creationId xmlns:a16="http://schemas.microsoft.com/office/drawing/2014/main" id="{AE37944C-7515-08B9-13C5-09EE26EDE998}"/>
+                </a:ext>
+              </a:extLst>
+            </p:cNvPr>
+            <p:cNvSpPr/>
+            <p:nvPr/>
+          </p:nvSpPr>
+          <p:spPr>
+            <a:xfrm>
+              <a:off x="1443600" y="1335600"/>
+              <a:ext cx="540000" cy="540000"/>
+            </a:xfrm>
+            <a:prstGeom prst="ellipse">
+              <a:avLst/>
+            </a:prstGeom>
+            <a:solidFill>
+              <a:srgbClr val="FA7902"/>
+            </a:solidFill>
+            <a:ln>
+              <a:noFill/>
+            </a:ln>
+          </p:spPr>
+          <p:style>
+            <a:lnRef idx="2">
+              <a:schemeClr val="accent1">
+                <a:shade val="15000"/>
+              </a:schemeClr>
+            </a:lnRef>
+            <a:fillRef idx="1">
+              <a:schemeClr val="accent1"/>
+            </a:fillRef>
+            <a:effectRef idx="0">
+              <a:schemeClr val="accent1"/>
+            </a:effectRef>
+            <a:fontRef idx="minor">
+              <a:schemeClr val="lt1"/>
+            </a:fontRef>
+          </p:style>
+          <p:txBody>
+            <a:bodyPr rtlCol="0" anchor="ctr"/>
+            <a:lstStyle/>
+            <a:p>
+              <a:pPr algn="ctr"/>
+              <a:endParaRPr lang="zh-CN" altLang="en-US"/>
+            </a:p>
+          </p:txBody>
+        </p:sp>
+      </p:grpSp>
     </p:spTree>
     <p:extLst>
       <p:ext uri="{BB962C8B-B14F-4D97-AF65-F5344CB8AC3E}">

</xml_diff>